<commit_message>
feat: diversify PPT style page grammars
</commit_message>
<xml_diff>
--- a/effect-tests/multi-style-pptx-v1/pptx/editorial-magazine.pptx
+++ b/effect-tests/multi-style-pptx-v1/pptx/editorial-magazine.pptx
@@ -900,8 +900,8 @@
         </p:nvSpPr>
         <p:spPr>
           <a:xfrm>
-            <a:off x="658368" y="713232"/>
-            <a:ext cx="5084064" cy="694944"/>
+            <a:off x="658368" y="621792"/>
+            <a:ext cx="4572000" cy="713232"/>
           </a:xfrm>
           <a:prstGeom prst="rect">
             <a:avLst/>
@@ -955,8 +955,8 @@
         </p:nvSpPr>
         <p:spPr>
           <a:xfrm>
-            <a:off x="694944" y="1463040"/>
-            <a:ext cx="4553712" cy="310896"/>
+            <a:off x="694944" y="1316736"/>
+            <a:ext cx="4114800" cy="310896"/>
           </a:xfrm>
           <a:prstGeom prst="rect">
             <a:avLst/>
@@ -996,20 +996,16 @@
         </p:nvSpPr>
         <p:spPr>
           <a:xfrm>
-            <a:off x="713232" y="1975104"/>
-            <a:ext cx="420624" cy="420624"/>
-          </a:xfrm>
-          <a:prstGeom prst="ellipse">
-            <a:avLst/>
-          </a:prstGeom>
-          <a:solidFill>
-            <a:srgbClr val="9D3340">
-              <a:alpha val="92000"/>
-            </a:srgbClr>
-          </a:solidFill>
+            <a:off x="786384" y="1828800"/>
+            <a:ext cx="3127248" cy="0"/>
+          </a:xfrm>
+          <a:prstGeom prst="line">
+            <a:avLst/>
+          </a:prstGeom>
+          <a:noFill/>
           <a:ln w="12700">
             <a:solidFill>
-              <a:srgbClr val="FFFFFF">
+              <a:srgbClr val="9D3340">
                 <a:alpha val="88000"/>
               </a:srgbClr>
             </a:solidFill>
@@ -1025,8 +1021,8 @@
         </p:nvSpPr>
         <p:spPr>
           <a:xfrm>
-            <a:off x="713232" y="2084832"/>
-            <a:ext cx="420624" cy="146304"/>
+            <a:off x="786384" y="1975104"/>
+            <a:ext cx="384048" cy="164592"/>
           </a:xfrm>
           <a:prstGeom prst="rect">
             <a:avLst/>
@@ -1038,21 +1034,21 @@
           <a:bodyPr wrap="square" lIns="0" tIns="0" rIns="0" bIns="0" rtlCol="0" anchor="ctr"/>
           <a:lstStyle/>
           <a:p>
-            <a:pPr algn="ctr" indent="0" marL="0">
-              <a:buNone/>
-            </a:pPr>
-            <a:r>
-              <a:rPr lang="en-US" sz="820" b="1" dirty="0">
-                <a:solidFill>
-                  <a:srgbClr val="FFFFFF"/>
-                </a:solidFill>
-                <a:latin typeface="PingFang SC" pitchFamily="34" charset="0"/>
-                <a:ea typeface="PingFang SC" pitchFamily="34" charset="-122"/>
-                <a:cs typeface="PingFang SC" pitchFamily="34" charset="-120"/>
-              </a:rPr>
-              <a:t>A</a:t>
-            </a:r>
-            <a:endParaRPr lang="en-US" sz="820" dirty="0"/>
+            <a:pPr indent="0" marL="0">
+              <a:buNone/>
+            </a:pPr>
+            <a:r>
+              <a:rPr lang="en-US" sz="760" b="1" dirty="0">
+                <a:solidFill>
+                  <a:srgbClr val="9D3340"/>
+                </a:solidFill>
+                <a:latin typeface="PingFang SC" pitchFamily="34" charset="0"/>
+                <a:ea typeface="PingFang SC" pitchFamily="34" charset="-122"/>
+                <a:cs typeface="PingFang SC" pitchFamily="34" charset="-120"/>
+              </a:rPr>
+              <a:t>01</a:t>
+            </a:r>
+            <a:endParaRPr lang="en-US" sz="760" dirty="0"/>
           </a:p>
         </p:txBody>
       </p:sp>
@@ -1064,8 +1060,8 @@
         </p:nvSpPr>
         <p:spPr>
           <a:xfrm>
-            <a:off x="1371600" y="1975104"/>
-            <a:ext cx="3840480" cy="256032"/>
+            <a:off x="1316736" y="1901952"/>
+            <a:ext cx="3739896" cy="274320"/>
           </a:xfrm>
           <a:prstGeom prst="rect">
             <a:avLst/>
@@ -1105,8 +1101,8 @@
         </p:nvSpPr>
         <p:spPr>
           <a:xfrm>
-            <a:off x="1371600" y="2286000"/>
-            <a:ext cx="3840480" cy="201168"/>
+            <a:off x="1316736" y="2249424"/>
+            <a:ext cx="3685032" cy="256032"/>
           </a:xfrm>
           <a:prstGeom prst="rect">
             <a:avLst/>
@@ -1146,21 +1142,17 @@
         </p:nvSpPr>
         <p:spPr>
           <a:xfrm>
-            <a:off x="713232" y="2651760"/>
-            <a:ext cx="420624" cy="420624"/>
-          </a:xfrm>
-          <a:prstGeom prst="ellipse">
-            <a:avLst/>
-          </a:prstGeom>
-          <a:solidFill>
-            <a:srgbClr val="D8B889">
-              <a:alpha val="92000"/>
-            </a:srgbClr>
-          </a:solidFill>
+            <a:off x="786384" y="2651760"/>
+            <a:ext cx="3127248" cy="0"/>
+          </a:xfrm>
+          <a:prstGeom prst="line">
+            <a:avLst/>
+          </a:prstGeom>
+          <a:noFill/>
           <a:ln w="12700">
             <a:solidFill>
-              <a:srgbClr val="FFFFFF">
-                <a:alpha val="88000"/>
+              <a:srgbClr val="D8B889">
+                <a:alpha val="58000"/>
               </a:srgbClr>
             </a:solidFill>
             <a:prstDash val="solid"/>
@@ -1175,8 +1167,8 @@
         </p:nvSpPr>
         <p:spPr>
           <a:xfrm>
-            <a:off x="713232" y="2761488"/>
-            <a:ext cx="420624" cy="146304"/>
+            <a:off x="786384" y="2798064"/>
+            <a:ext cx="384048" cy="164592"/>
           </a:xfrm>
           <a:prstGeom prst="rect">
             <a:avLst/>
@@ -1188,21 +1180,21 @@
           <a:bodyPr wrap="square" lIns="0" tIns="0" rIns="0" bIns="0" rtlCol="0" anchor="ctr"/>
           <a:lstStyle/>
           <a:p>
-            <a:pPr algn="ctr" indent="0" marL="0">
-              <a:buNone/>
-            </a:pPr>
-            <a:r>
-              <a:rPr lang="en-US" sz="820" b="1" dirty="0">
-                <a:solidFill>
-                  <a:srgbClr val="FFFFFF"/>
-                </a:solidFill>
-                <a:latin typeface="PingFang SC" pitchFamily="34" charset="0"/>
-                <a:ea typeface="PingFang SC" pitchFamily="34" charset="-122"/>
-                <a:cs typeface="PingFang SC" pitchFamily="34" charset="-120"/>
-              </a:rPr>
-              <a:t>B</a:t>
-            </a:r>
-            <a:endParaRPr lang="en-US" sz="820" dirty="0"/>
+            <a:pPr indent="0" marL="0">
+              <a:buNone/>
+            </a:pPr>
+            <a:r>
+              <a:rPr lang="en-US" sz="760" b="1" dirty="0">
+                <a:solidFill>
+                  <a:srgbClr val="D8B889"/>
+                </a:solidFill>
+                <a:latin typeface="PingFang SC" pitchFamily="34" charset="0"/>
+                <a:ea typeface="PingFang SC" pitchFamily="34" charset="-122"/>
+                <a:cs typeface="PingFang SC" pitchFamily="34" charset="-120"/>
+              </a:rPr>
+              <a:t>02</a:t>
+            </a:r>
+            <a:endParaRPr lang="en-US" sz="760" dirty="0"/>
           </a:p>
         </p:txBody>
       </p:sp>
@@ -1214,8 +1206,8 @@
         </p:nvSpPr>
         <p:spPr>
           <a:xfrm>
-            <a:off x="1371600" y="2651760"/>
-            <a:ext cx="3840480" cy="256032"/>
+            <a:off x="1316736" y="2724912"/>
+            <a:ext cx="3739896" cy="274320"/>
           </a:xfrm>
           <a:prstGeom prst="rect">
             <a:avLst/>
@@ -1255,8 +1247,8 @@
         </p:nvSpPr>
         <p:spPr>
           <a:xfrm>
-            <a:off x="1371600" y="2962656"/>
-            <a:ext cx="3840480" cy="201168"/>
+            <a:off x="1316736" y="3072384"/>
+            <a:ext cx="3685032" cy="256032"/>
           </a:xfrm>
           <a:prstGeom prst="rect">
             <a:avLst/>
@@ -1296,21 +1288,17 @@
         </p:nvSpPr>
         <p:spPr>
           <a:xfrm>
-            <a:off x="713232" y="3328416"/>
-            <a:ext cx="420624" cy="420624"/>
-          </a:xfrm>
-          <a:prstGeom prst="ellipse">
-            <a:avLst/>
-          </a:prstGeom>
-          <a:solidFill>
-            <a:srgbClr val="6F7E8B">
-              <a:alpha val="92000"/>
-            </a:srgbClr>
-          </a:solidFill>
+            <a:off x="786384" y="3474720"/>
+            <a:ext cx="3127248" cy="0"/>
+          </a:xfrm>
+          <a:prstGeom prst="line">
+            <a:avLst/>
+          </a:prstGeom>
+          <a:noFill/>
           <a:ln w="12700">
             <a:solidFill>
-              <a:srgbClr val="FFFFFF">
-                <a:alpha val="88000"/>
+              <a:srgbClr val="6F7E8B">
+                <a:alpha val="58000"/>
               </a:srgbClr>
             </a:solidFill>
             <a:prstDash val="solid"/>
@@ -1325,8 +1313,8 @@
         </p:nvSpPr>
         <p:spPr>
           <a:xfrm>
-            <a:off x="713232" y="3438144"/>
-            <a:ext cx="420624" cy="146304"/>
+            <a:off x="786384" y="3621024"/>
+            <a:ext cx="384048" cy="164592"/>
           </a:xfrm>
           <a:prstGeom prst="rect">
             <a:avLst/>
@@ -1338,21 +1326,21 @@
           <a:bodyPr wrap="square" lIns="0" tIns="0" rIns="0" bIns="0" rtlCol="0" anchor="ctr"/>
           <a:lstStyle/>
           <a:p>
-            <a:pPr algn="ctr" indent="0" marL="0">
-              <a:buNone/>
-            </a:pPr>
-            <a:r>
-              <a:rPr lang="en-US" sz="820" b="1" dirty="0">
-                <a:solidFill>
-                  <a:srgbClr val="FFFFFF"/>
-                </a:solidFill>
-                <a:latin typeface="PingFang SC" pitchFamily="34" charset="0"/>
-                <a:ea typeface="PingFang SC" pitchFamily="34" charset="-122"/>
-                <a:cs typeface="PingFang SC" pitchFamily="34" charset="-120"/>
-              </a:rPr>
-              <a:t>C</a:t>
-            </a:r>
-            <a:endParaRPr lang="en-US" sz="820" dirty="0"/>
+            <a:pPr indent="0" marL="0">
+              <a:buNone/>
+            </a:pPr>
+            <a:r>
+              <a:rPr lang="en-US" sz="760" b="1" dirty="0">
+                <a:solidFill>
+                  <a:srgbClr val="6F7E8B"/>
+                </a:solidFill>
+                <a:latin typeface="PingFang SC" pitchFamily="34" charset="0"/>
+                <a:ea typeface="PingFang SC" pitchFamily="34" charset="-122"/>
+                <a:cs typeface="PingFang SC" pitchFamily="34" charset="-120"/>
+              </a:rPr>
+              <a:t>03</a:t>
+            </a:r>
+            <a:endParaRPr lang="en-US" sz="760" dirty="0"/>
           </a:p>
         </p:txBody>
       </p:sp>
@@ -1364,8 +1352,8 @@
         </p:nvSpPr>
         <p:spPr>
           <a:xfrm>
-            <a:off x="1371600" y="3328416"/>
-            <a:ext cx="3840480" cy="256032"/>
+            <a:off x="1316736" y="3547872"/>
+            <a:ext cx="3739896" cy="274320"/>
           </a:xfrm>
           <a:prstGeom prst="rect">
             <a:avLst/>
@@ -1405,8 +1393,8 @@
         </p:nvSpPr>
         <p:spPr>
           <a:xfrm>
-            <a:off x="1371600" y="3639312"/>
-            <a:ext cx="3840480" cy="201168"/>
+            <a:off x="1316736" y="3895344"/>
+            <a:ext cx="3685032" cy="256032"/>
           </a:xfrm>
           <a:prstGeom prst="rect">
             <a:avLst/>
@@ -1440,39 +1428,14 @@
       </p:sp>
       <p:sp>
         <p:nvSpPr>
-          <p:cNvPr id="17" name="Shape 14"/>
-          <p:cNvSpPr/>
-          <p:nvPr/>
-        </p:nvSpPr>
-        <p:spPr>
-          <a:xfrm>
-            <a:off x="329184" y="4782312"/>
-            <a:ext cx="5276088" cy="0"/>
-          </a:xfrm>
-          <a:prstGeom prst="line">
-            <a:avLst/>
-          </a:prstGeom>
-          <a:noFill/>
-          <a:ln w="12700">
-            <a:solidFill>
-              <a:srgbClr val="6A625C">
-                <a:alpha val="76000"/>
-              </a:srgbClr>
-            </a:solidFill>
-            <a:prstDash val="solid"/>
-          </a:ln>
-        </p:spPr>
-      </p:sp>
-      <p:sp>
-        <p:nvSpPr>
-          <p:cNvPr id="18" name="Text 15"/>
-          <p:cNvSpPr/>
-          <p:nvPr/>
-        </p:nvSpPr>
-        <p:spPr>
-          <a:xfrm>
-            <a:off x="786384" y="5010912"/>
-            <a:ext cx="1301496" cy="365760"/>
+          <p:cNvPr id="17" name="Text 14"/>
+          <p:cNvSpPr/>
+          <p:nvPr/>
+        </p:nvSpPr>
+        <p:spPr>
+          <a:xfrm>
+            <a:off x="5468112" y="1060704"/>
+            <a:ext cx="3931920" cy="329184"/>
           </a:xfrm>
           <a:prstGeom prst="rect">
             <a:avLst/>
@@ -1486,147 +1449,11 @@
           </a:bodyPr>
           <a:lstStyle/>
           <a:p>
-            <a:pPr algn="ctr" indent="0" marL="0">
-              <a:buNone/>
-            </a:pPr>
-            <a:r>
-              <a:rPr lang="en-US" sz="1820" b="1" dirty="0">
-                <a:solidFill>
-                  <a:srgbClr val="D8B889"/>
-                </a:solidFill>
-                <a:latin typeface="PingFang SC" pitchFamily="34" charset="0"/>
-                <a:ea typeface="PingFang SC" pitchFamily="34" charset="-122"/>
-                <a:cs typeface="PingFang SC" pitchFamily="34" charset="-120"/>
-              </a:rPr>
-              <a:t>57%</a:t>
-            </a:r>
-            <a:endParaRPr lang="en-US" sz="1820" dirty="0"/>
-          </a:p>
-        </p:txBody>
-      </p:sp>
-      <p:sp>
-        <p:nvSpPr>
-          <p:cNvPr id="19" name="Text 16"/>
-          <p:cNvSpPr/>
-          <p:nvPr/>
-        </p:nvSpPr>
-        <p:spPr>
-          <a:xfrm>
-            <a:off x="786384" y="5422392"/>
-            <a:ext cx="1301496" cy="201168"/>
-          </a:xfrm>
-          <a:prstGeom prst="rect">
-            <a:avLst/>
-          </a:prstGeom>
-          <a:noFill/>
-          <a:ln/>
-        </p:spPr>
-        <p:txBody>
-          <a:bodyPr wrap="square" lIns="0" tIns="0" rIns="0" bIns="0" rtlCol="0" anchor="ctr">
-            <a:normAutofit/>
-          </a:bodyPr>
-          <a:lstStyle/>
-          <a:p>
-            <a:pPr algn="ctr" indent="0" marL="0">
-              <a:buNone/>
-            </a:pPr>
-            <a:r>
-              <a:rPr lang="en-US" sz="700" b="1" dirty="0">
-                <a:solidFill>
-                  <a:srgbClr val="D8CFC5"/>
-                </a:solidFill>
-                <a:latin typeface="PingFang SC" pitchFamily="34" charset="0"/>
-                <a:ea typeface="PingFang SC" pitchFamily="34" charset="-122"/>
-                <a:cs typeface="PingFang SC" pitchFamily="34" charset="-120"/>
-              </a:rPr>
-              <a:t>选题复用</a:t>
-            </a:r>
-            <a:endParaRPr lang="en-US" sz="700" dirty="0"/>
-          </a:p>
-        </p:txBody>
-      </p:sp>
-      <p:sp>
-        <p:nvSpPr>
-          <p:cNvPr id="20" name="Shape 17"/>
-          <p:cNvSpPr/>
-          <p:nvPr/>
-        </p:nvSpPr>
-        <p:spPr>
-          <a:xfrm>
-            <a:off x="1359408" y="5678424"/>
-            <a:ext cx="292608" cy="292608"/>
-          </a:xfrm>
-          <a:prstGeom prst="ellipse">
-            <a:avLst/>
-          </a:prstGeom>
-          <a:solidFill>
-            <a:srgbClr val="D8B889">
-              <a:alpha val="42000"/>
-            </a:srgbClr>
-          </a:solidFill>
-          <a:ln w="12700">
-            <a:solidFill>
-              <a:srgbClr val="1F1C1A">
-                <a:alpha val="80000"/>
-              </a:srgbClr>
-            </a:solidFill>
-            <a:prstDash val="solid"/>
-          </a:ln>
-        </p:spPr>
-      </p:sp>
-      <p:sp>
-        <p:nvSpPr>
-          <p:cNvPr id="21" name="Shape 18"/>
-          <p:cNvSpPr/>
-          <p:nvPr/>
-        </p:nvSpPr>
-        <p:spPr>
-          <a:xfrm>
-            <a:off x="2115312" y="5065776"/>
-            <a:ext cx="0" cy="749808"/>
-          </a:xfrm>
-          <a:prstGeom prst="line">
-            <a:avLst/>
-          </a:prstGeom>
-          <a:noFill/>
-          <a:ln w="12700">
-            <a:solidFill>
-              <a:srgbClr val="6A625C">
-                <a:alpha val="62000"/>
-              </a:srgbClr>
-            </a:solidFill>
-            <a:prstDash val="solid"/>
-          </a:ln>
-        </p:spPr>
-      </p:sp>
-      <p:sp>
-        <p:nvSpPr>
-          <p:cNvPr id="22" name="Text 19"/>
-          <p:cNvSpPr/>
-          <p:nvPr/>
-        </p:nvSpPr>
-        <p:spPr>
-          <a:xfrm>
-            <a:off x="2225040" y="5010912"/>
-            <a:ext cx="1301496" cy="365760"/>
-          </a:xfrm>
-          <a:prstGeom prst="rect">
-            <a:avLst/>
-          </a:prstGeom>
-          <a:noFill/>
-          <a:ln/>
-        </p:spPr>
-        <p:txBody>
-          <a:bodyPr wrap="square" lIns="0" tIns="0" rIns="0" bIns="0" rtlCol="0" anchor="ctr">
-            <a:normAutofit/>
-          </a:bodyPr>
-          <a:lstStyle/>
-          <a:p>
-            <a:pPr algn="ctr" indent="0" marL="0">
-              <a:buNone/>
-            </a:pPr>
-            <a:r>
-              <a:rPr lang="en-US" sz="1820" b="1" dirty="0">
+            <a:pPr indent="0" marL="0">
+              <a:buNone/>
+            </a:pPr>
+            <a:r>
+              <a:rPr lang="en-US" sz="1140" b="1" dirty="0">
                 <a:solidFill>
                   <a:srgbClr val="F5EFE6"/>
                 </a:solidFill>
@@ -1634,253 +1461,6 @@
                 <a:ea typeface="PingFang SC" pitchFamily="34" charset="-122"/>
                 <a:cs typeface="PingFang SC" pitchFamily="34" charset="-120"/>
               </a:rPr>
-              <a:t>2.8x</a:t>
-            </a:r>
-            <a:endParaRPr lang="en-US" sz="1820" dirty="0"/>
-          </a:p>
-        </p:txBody>
-      </p:sp>
-      <p:sp>
-        <p:nvSpPr>
-          <p:cNvPr id="23" name="Text 20"/>
-          <p:cNvSpPr/>
-          <p:nvPr/>
-        </p:nvSpPr>
-        <p:spPr>
-          <a:xfrm>
-            <a:off x="2225040" y="5422392"/>
-            <a:ext cx="1301496" cy="201168"/>
-          </a:xfrm>
-          <a:prstGeom prst="rect">
-            <a:avLst/>
-          </a:prstGeom>
-          <a:noFill/>
-          <a:ln/>
-        </p:spPr>
-        <p:txBody>
-          <a:bodyPr wrap="square" lIns="0" tIns="0" rIns="0" bIns="0" rtlCol="0" anchor="ctr">
-            <a:normAutofit/>
-          </a:bodyPr>
-          <a:lstStyle/>
-          <a:p>
-            <a:pPr algn="ctr" indent="0" marL="0">
-              <a:buNone/>
-            </a:pPr>
-            <a:r>
-              <a:rPr lang="en-US" sz="700" b="1" dirty="0">
-                <a:solidFill>
-                  <a:srgbClr val="D8CFC5"/>
-                </a:solidFill>
-                <a:latin typeface="PingFang SC" pitchFamily="34" charset="0"/>
-                <a:ea typeface="PingFang SC" pitchFamily="34" charset="-122"/>
-                <a:cs typeface="PingFang SC" pitchFamily="34" charset="-120"/>
-              </a:rPr>
-              <a:t>审稿提速</a:t>
-            </a:r>
-            <a:endParaRPr lang="en-US" sz="700" dirty="0"/>
-          </a:p>
-        </p:txBody>
-      </p:sp>
-      <p:sp>
-        <p:nvSpPr>
-          <p:cNvPr id="24" name="Shape 21"/>
-          <p:cNvSpPr/>
-          <p:nvPr/>
-        </p:nvSpPr>
-        <p:spPr>
-          <a:xfrm>
-            <a:off x="2798064" y="5678424"/>
-            <a:ext cx="292608" cy="292608"/>
-          </a:xfrm>
-          <a:prstGeom prst="ellipse">
-            <a:avLst/>
-          </a:prstGeom>
-          <a:solidFill>
-            <a:srgbClr val="F5EFE6">
-              <a:alpha val="42000"/>
-            </a:srgbClr>
-          </a:solidFill>
-          <a:ln w="12700">
-            <a:solidFill>
-              <a:srgbClr val="1F1C1A">
-                <a:alpha val="80000"/>
-              </a:srgbClr>
-            </a:solidFill>
-            <a:prstDash val="solid"/>
-          </a:ln>
-        </p:spPr>
-      </p:sp>
-      <p:sp>
-        <p:nvSpPr>
-          <p:cNvPr id="25" name="Shape 22"/>
-          <p:cNvSpPr/>
-          <p:nvPr/>
-        </p:nvSpPr>
-        <p:spPr>
-          <a:xfrm>
-            <a:off x="3553968" y="5065776"/>
-            <a:ext cx="0" cy="749808"/>
-          </a:xfrm>
-          <a:prstGeom prst="line">
-            <a:avLst/>
-          </a:prstGeom>
-          <a:noFill/>
-          <a:ln w="12700">
-            <a:solidFill>
-              <a:srgbClr val="6A625C">
-                <a:alpha val="62000"/>
-              </a:srgbClr>
-            </a:solidFill>
-            <a:prstDash val="solid"/>
-          </a:ln>
-        </p:spPr>
-      </p:sp>
-      <p:sp>
-        <p:nvSpPr>
-          <p:cNvPr id="26" name="Text 23"/>
-          <p:cNvSpPr/>
-          <p:nvPr/>
-        </p:nvSpPr>
-        <p:spPr>
-          <a:xfrm>
-            <a:off x="3663696" y="5010912"/>
-            <a:ext cx="1301496" cy="365760"/>
-          </a:xfrm>
-          <a:prstGeom prst="rect">
-            <a:avLst/>
-          </a:prstGeom>
-          <a:noFill/>
-          <a:ln/>
-        </p:spPr>
-        <p:txBody>
-          <a:bodyPr wrap="square" lIns="0" tIns="0" rIns="0" bIns="0" rtlCol="0" anchor="ctr">
-            <a:normAutofit/>
-          </a:bodyPr>
-          <a:lstStyle/>
-          <a:p>
-            <a:pPr algn="ctr" indent="0" marL="0">
-              <a:buNone/>
-            </a:pPr>
-            <a:r>
-              <a:rPr lang="en-US" sz="1820" b="1" dirty="0">
-                <a:solidFill>
-                  <a:srgbClr val="9D3340"/>
-                </a:solidFill>
-                <a:latin typeface="PingFang SC" pitchFamily="34" charset="0"/>
-                <a:ea typeface="PingFang SC" pitchFamily="34" charset="-122"/>
-                <a:cs typeface="PingFang SC" pitchFamily="34" charset="-120"/>
-              </a:rPr>
-              <a:t>2026</a:t>
-            </a:r>
-            <a:endParaRPr lang="en-US" sz="1820" dirty="0"/>
-          </a:p>
-        </p:txBody>
-      </p:sp>
-      <p:sp>
-        <p:nvSpPr>
-          <p:cNvPr id="27" name="Text 24"/>
-          <p:cNvSpPr/>
-          <p:nvPr/>
-        </p:nvSpPr>
-        <p:spPr>
-          <a:xfrm>
-            <a:off x="3663696" y="5422392"/>
-            <a:ext cx="1301496" cy="201168"/>
-          </a:xfrm>
-          <a:prstGeom prst="rect">
-            <a:avLst/>
-          </a:prstGeom>
-          <a:noFill/>
-          <a:ln/>
-        </p:spPr>
-        <p:txBody>
-          <a:bodyPr wrap="square" lIns="0" tIns="0" rIns="0" bIns="0" rtlCol="0" anchor="ctr">
-            <a:normAutofit/>
-          </a:bodyPr>
-          <a:lstStyle/>
-          <a:p>
-            <a:pPr algn="ctr" indent="0" marL="0">
-              <a:buNone/>
-            </a:pPr>
-            <a:r>
-              <a:rPr lang="en-US" sz="700" b="1" dirty="0">
-                <a:solidFill>
-                  <a:srgbClr val="D8CFC5"/>
-                </a:solidFill>
-                <a:latin typeface="PingFang SC" pitchFamily="34" charset="0"/>
-                <a:ea typeface="PingFang SC" pitchFamily="34" charset="-122"/>
-                <a:cs typeface="PingFang SC" pitchFamily="34" charset="-120"/>
-              </a:rPr>
-              <a:t>内容复利</a:t>
-            </a:r>
-            <a:endParaRPr lang="en-US" sz="700" dirty="0"/>
-          </a:p>
-        </p:txBody>
-      </p:sp>
-      <p:sp>
-        <p:nvSpPr>
-          <p:cNvPr id="28" name="Shape 25"/>
-          <p:cNvSpPr/>
-          <p:nvPr/>
-        </p:nvSpPr>
-        <p:spPr>
-          <a:xfrm>
-            <a:off x="4236720" y="5678424"/>
-            <a:ext cx="292608" cy="292608"/>
-          </a:xfrm>
-          <a:prstGeom prst="ellipse">
-            <a:avLst/>
-          </a:prstGeom>
-          <a:solidFill>
-            <a:srgbClr val="9D3340">
-              <a:alpha val="42000"/>
-            </a:srgbClr>
-          </a:solidFill>
-          <a:ln w="12700">
-            <a:solidFill>
-              <a:srgbClr val="1F1C1A">
-                <a:alpha val="80000"/>
-              </a:srgbClr>
-            </a:solidFill>
-            <a:prstDash val="solid"/>
-          </a:ln>
-        </p:spPr>
-      </p:sp>
-      <p:sp>
-        <p:nvSpPr>
-          <p:cNvPr id="29" name="Text 26"/>
-          <p:cNvSpPr/>
-          <p:nvPr/>
-        </p:nvSpPr>
-        <p:spPr>
-          <a:xfrm>
-            <a:off x="5760720" y="822960"/>
-            <a:ext cx="3840480" cy="365760"/>
-          </a:xfrm>
-          <a:prstGeom prst="rect">
-            <a:avLst/>
-          </a:prstGeom>
-          <a:noFill/>
-          <a:ln/>
-        </p:spPr>
-        <p:txBody>
-          <a:bodyPr wrap="square" lIns="0" tIns="0" rIns="0" bIns="0" rtlCol="0" anchor="ctr">
-            <a:normAutofit/>
-          </a:bodyPr>
-          <a:lstStyle/>
-          <a:p>
-            <a:pPr indent="0" marL="0">
-              <a:buNone/>
-            </a:pPr>
-            <a:r>
-              <a:rPr lang="en-US" sz="1140" b="1" dirty="0">
-                <a:solidFill>
-                  <a:srgbClr val="F5EFE6"/>
-                </a:solidFill>
-                <a:latin typeface="PingFang SC" pitchFamily="34" charset="0"/>
-                <a:ea typeface="PingFang SC" pitchFamily="34" charset="-122"/>
-                <a:cs typeface="PingFang SC" pitchFamily="34" charset="-120"/>
-              </a:rPr>
               <a:t>内容资产复利指数</a:t>
             </a:r>
             <a:endParaRPr lang="en-US" sz="1140" dirty="0"/>
@@ -1889,13 +1469,13 @@
       </p:sp>
       <p:sp>
         <p:nvSpPr>
-          <p:cNvPr id="30" name="Shape 27"/>
-          <p:cNvSpPr/>
-          <p:nvPr/>
-        </p:nvSpPr>
-        <p:spPr>
-          <a:xfrm>
-            <a:off x="5760720" y="1207008"/>
+          <p:cNvPr id="18" name="Shape 15"/>
+          <p:cNvSpPr/>
+          <p:nvPr/>
+        </p:nvSpPr>
+        <p:spPr>
+          <a:xfrm>
+            <a:off x="5468112" y="1444752"/>
             <a:ext cx="292608" cy="0"/>
           </a:xfrm>
           <a:prstGeom prst="line">
@@ -1912,14 +1492,14 @@
       </p:sp>
       <p:sp>
         <p:nvSpPr>
-          <p:cNvPr id="31" name="Shape 28"/>
-          <p:cNvSpPr/>
-          <p:nvPr/>
-        </p:nvSpPr>
-        <p:spPr>
-          <a:xfrm>
-            <a:off x="5971032" y="3813048"/>
-            <a:ext cx="3575304" cy="0"/>
+          <p:cNvPr id="19" name="Shape 16"/>
+          <p:cNvSpPr/>
+          <p:nvPr/>
+        </p:nvSpPr>
+        <p:spPr>
+          <a:xfrm>
+            <a:off x="5769864" y="3931920"/>
+            <a:ext cx="4050792" cy="0"/>
           </a:xfrm>
           <a:prstGeom prst="line">
             <a:avLst/>
@@ -1937,13 +1517,13 @@
       </p:sp>
       <p:sp>
         <p:nvSpPr>
-          <p:cNvPr id="32" name="Text 29"/>
-          <p:cNvSpPr/>
-          <p:nvPr/>
-        </p:nvSpPr>
-        <p:spPr>
-          <a:xfrm>
-            <a:off x="5641848" y="3749040"/>
+          <p:cNvPr id="20" name="Text 17"/>
+          <p:cNvSpPr/>
+          <p:nvPr/>
+        </p:nvSpPr>
+        <p:spPr>
+          <a:xfrm>
+            <a:off x="5440680" y="3867912"/>
             <a:ext cx="228600" cy="109728"/>
           </a:xfrm>
           <a:prstGeom prst="rect">
@@ -1976,14 +1556,14 @@
       </p:sp>
       <p:sp>
         <p:nvSpPr>
-          <p:cNvPr id="33" name="Shape 30"/>
-          <p:cNvSpPr/>
-          <p:nvPr/>
-        </p:nvSpPr>
-        <p:spPr>
-          <a:xfrm>
-            <a:off x="5971032" y="3257550"/>
-            <a:ext cx="3575304" cy="0"/>
+          <p:cNvPr id="21" name="Shape 18"/>
+          <p:cNvSpPr/>
+          <p:nvPr/>
+        </p:nvSpPr>
+        <p:spPr>
+          <a:xfrm>
+            <a:off x="5769864" y="3451860"/>
+            <a:ext cx="4050792" cy="0"/>
           </a:xfrm>
           <a:prstGeom prst="line">
             <a:avLst/>
@@ -2001,13 +1581,13 @@
       </p:sp>
       <p:sp>
         <p:nvSpPr>
-          <p:cNvPr id="34" name="Text 31"/>
-          <p:cNvSpPr/>
-          <p:nvPr/>
-        </p:nvSpPr>
-        <p:spPr>
-          <a:xfrm>
-            <a:off x="5641848" y="3193542"/>
+          <p:cNvPr id="22" name="Text 19"/>
+          <p:cNvSpPr/>
+          <p:nvPr/>
+        </p:nvSpPr>
+        <p:spPr>
+          <a:xfrm>
+            <a:off x="5440680" y="3387852"/>
             <a:ext cx="228600" cy="109728"/>
           </a:xfrm>
           <a:prstGeom prst="rect">
@@ -2040,14 +1620,14 @@
       </p:sp>
       <p:sp>
         <p:nvSpPr>
-          <p:cNvPr id="35" name="Shape 32"/>
-          <p:cNvSpPr/>
-          <p:nvPr/>
-        </p:nvSpPr>
-        <p:spPr>
-          <a:xfrm>
-            <a:off x="5971032" y="2702052"/>
-            <a:ext cx="3575304" cy="0"/>
+          <p:cNvPr id="23" name="Shape 20"/>
+          <p:cNvSpPr/>
+          <p:nvPr/>
+        </p:nvSpPr>
+        <p:spPr>
+          <a:xfrm>
+            <a:off x="5769864" y="2971800"/>
+            <a:ext cx="4050792" cy="0"/>
           </a:xfrm>
           <a:prstGeom prst="line">
             <a:avLst/>
@@ -2065,13 +1645,13 @@
       </p:sp>
       <p:sp>
         <p:nvSpPr>
-          <p:cNvPr id="36" name="Text 33"/>
-          <p:cNvSpPr/>
-          <p:nvPr/>
-        </p:nvSpPr>
-        <p:spPr>
-          <a:xfrm>
-            <a:off x="5641848" y="2638044"/>
+          <p:cNvPr id="24" name="Text 21"/>
+          <p:cNvSpPr/>
+          <p:nvPr/>
+        </p:nvSpPr>
+        <p:spPr>
+          <a:xfrm>
+            <a:off x="5440680" y="2907792"/>
             <a:ext cx="228600" cy="109728"/>
           </a:xfrm>
           <a:prstGeom prst="rect">
@@ -2104,14 +1684,14 @@
       </p:sp>
       <p:sp>
         <p:nvSpPr>
-          <p:cNvPr id="37" name="Shape 34"/>
-          <p:cNvSpPr/>
-          <p:nvPr/>
-        </p:nvSpPr>
-        <p:spPr>
-          <a:xfrm>
-            <a:off x="5971032" y="2146554"/>
-            <a:ext cx="3575304" cy="0"/>
+          <p:cNvPr id="25" name="Shape 22"/>
+          <p:cNvSpPr/>
+          <p:nvPr/>
+        </p:nvSpPr>
+        <p:spPr>
+          <a:xfrm>
+            <a:off x="5769864" y="2491740"/>
+            <a:ext cx="4050792" cy="0"/>
           </a:xfrm>
           <a:prstGeom prst="line">
             <a:avLst/>
@@ -2129,13 +1709,13 @@
       </p:sp>
       <p:sp>
         <p:nvSpPr>
-          <p:cNvPr id="38" name="Text 35"/>
-          <p:cNvSpPr/>
-          <p:nvPr/>
-        </p:nvSpPr>
-        <p:spPr>
-          <a:xfrm>
-            <a:off x="5641848" y="2082546"/>
+          <p:cNvPr id="26" name="Text 23"/>
+          <p:cNvSpPr/>
+          <p:nvPr/>
+        </p:nvSpPr>
+        <p:spPr>
+          <a:xfrm>
+            <a:off x="5440680" y="2427732"/>
             <a:ext cx="228600" cy="109728"/>
           </a:xfrm>
           <a:prstGeom prst="rect">
@@ -2168,14 +1748,14 @@
       </p:sp>
       <p:sp>
         <p:nvSpPr>
-          <p:cNvPr id="39" name="Shape 36"/>
-          <p:cNvSpPr/>
-          <p:nvPr/>
-        </p:nvSpPr>
-        <p:spPr>
-          <a:xfrm>
-            <a:off x="5971032" y="1591056"/>
-            <a:ext cx="3575304" cy="0"/>
+          <p:cNvPr id="27" name="Shape 24"/>
+          <p:cNvSpPr/>
+          <p:nvPr/>
+        </p:nvSpPr>
+        <p:spPr>
+          <a:xfrm>
+            <a:off x="5769864" y="2011680"/>
+            <a:ext cx="4050792" cy="0"/>
           </a:xfrm>
           <a:prstGeom prst="line">
             <a:avLst/>
@@ -2193,13 +1773,13 @@
       </p:sp>
       <p:sp>
         <p:nvSpPr>
-          <p:cNvPr id="40" name="Text 37"/>
-          <p:cNvSpPr/>
-          <p:nvPr/>
-        </p:nvSpPr>
-        <p:spPr>
-          <a:xfrm>
-            <a:off x="5641848" y="1527048"/>
+          <p:cNvPr id="28" name="Text 25"/>
+          <p:cNvSpPr/>
+          <p:nvPr/>
+        </p:nvSpPr>
+        <p:spPr>
+          <a:xfrm>
+            <a:off x="5440680" y="1947672"/>
             <a:ext cx="228600" cy="109728"/>
           </a:xfrm>
           <a:prstGeom prst="rect">
@@ -2232,14 +1812,14 @@
       </p:sp>
       <p:sp>
         <p:nvSpPr>
-          <p:cNvPr id="41" name="Shape 38"/>
-          <p:cNvSpPr/>
-          <p:nvPr/>
-        </p:nvSpPr>
-        <p:spPr>
-          <a:xfrm>
-            <a:off x="6262154" y="2754447"/>
-            <a:ext cx="311582" cy="1058601"/>
+          <p:cNvPr id="29" name="Shape 26"/>
+          <p:cNvSpPr/>
+          <p:nvPr/>
+        </p:nvSpPr>
+        <p:spPr>
+          <a:xfrm>
+            <a:off x="6085949" y="3027213"/>
+            <a:ext cx="380528" cy="904707"/>
           </a:xfrm>
           <a:prstGeom prst="rect">
             <a:avLst/>
@@ -2261,14 +1841,14 @@
       </p:sp>
       <p:sp>
         <p:nvSpPr>
-          <p:cNvPr id="42" name="Text 39"/>
-          <p:cNvSpPr/>
-          <p:nvPr/>
-        </p:nvSpPr>
-        <p:spPr>
-          <a:xfrm>
-            <a:off x="6152426" y="2516703"/>
-            <a:ext cx="531038" cy="164592"/>
+          <p:cNvPr id="30" name="Text 27"/>
+          <p:cNvSpPr/>
+          <p:nvPr/>
+        </p:nvSpPr>
+        <p:spPr>
+          <a:xfrm>
+            <a:off x="5976221" y="2789469"/>
+            <a:ext cx="599984" cy="164592"/>
           </a:xfrm>
           <a:prstGeom prst="rect">
             <a:avLst/>
@@ -2302,14 +1882,14 @@
       </p:sp>
       <p:sp>
         <p:nvSpPr>
-          <p:cNvPr id="43" name="Text 40"/>
-          <p:cNvSpPr/>
-          <p:nvPr/>
-        </p:nvSpPr>
-        <p:spPr>
-          <a:xfrm>
-            <a:off x="5998464" y="3941064"/>
-            <a:ext cx="838962" cy="310896"/>
+          <p:cNvPr id="31" name="Text 28"/>
+          <p:cNvSpPr/>
+          <p:nvPr/>
+        </p:nvSpPr>
+        <p:spPr>
+          <a:xfrm>
+            <a:off x="5797296" y="4059936"/>
+            <a:ext cx="957834" cy="310896"/>
           </a:xfrm>
           <a:prstGeom prst="rect">
             <a:avLst/>
@@ -2360,14 +1940,14 @@
       </p:sp>
       <p:sp>
         <p:nvSpPr>
-          <p:cNvPr id="44" name="Shape 41"/>
-          <p:cNvSpPr/>
-          <p:nvPr/>
-        </p:nvSpPr>
-        <p:spPr>
-          <a:xfrm>
-            <a:off x="7155980" y="2505365"/>
-            <a:ext cx="311582" cy="1307683"/>
+          <p:cNvPr id="32" name="Shape 29"/>
+          <p:cNvSpPr/>
+          <p:nvPr/>
+        </p:nvSpPr>
+        <p:spPr>
+          <a:xfrm>
+            <a:off x="7098647" y="2814340"/>
+            <a:ext cx="380528" cy="1117580"/>
           </a:xfrm>
           <a:prstGeom prst="rect">
             <a:avLst/>
@@ -2389,14 +1969,14 @@
       </p:sp>
       <p:sp>
         <p:nvSpPr>
-          <p:cNvPr id="45" name="Text 42"/>
-          <p:cNvSpPr/>
-          <p:nvPr/>
-        </p:nvSpPr>
-        <p:spPr>
-          <a:xfrm>
-            <a:off x="7046252" y="2267621"/>
-            <a:ext cx="531038" cy="164592"/>
+          <p:cNvPr id="33" name="Text 30"/>
+          <p:cNvSpPr/>
+          <p:nvPr/>
+        </p:nvSpPr>
+        <p:spPr>
+          <a:xfrm>
+            <a:off x="6988919" y="2576596"/>
+            <a:ext cx="599984" cy="164592"/>
           </a:xfrm>
           <a:prstGeom prst="rect">
             <a:avLst/>
@@ -2430,14 +2010,14 @@
       </p:sp>
       <p:sp>
         <p:nvSpPr>
-          <p:cNvPr id="46" name="Text 43"/>
-          <p:cNvSpPr/>
-          <p:nvPr/>
-        </p:nvSpPr>
-        <p:spPr>
-          <a:xfrm>
-            <a:off x="6892290" y="3941064"/>
-            <a:ext cx="838962" cy="310896"/>
+          <p:cNvPr id="34" name="Text 31"/>
+          <p:cNvSpPr/>
+          <p:nvPr/>
+        </p:nvSpPr>
+        <p:spPr>
+          <a:xfrm>
+            <a:off x="6809994" y="4059936"/>
+            <a:ext cx="957834" cy="310896"/>
           </a:xfrm>
           <a:prstGeom prst="rect">
             <a:avLst/>
@@ -2488,14 +2068,14 @@
       </p:sp>
       <p:sp>
         <p:nvSpPr>
-          <p:cNvPr id="47" name="Shape 44"/>
-          <p:cNvSpPr/>
-          <p:nvPr/>
-        </p:nvSpPr>
-        <p:spPr>
-          <a:xfrm>
-            <a:off x="8049806" y="2173254"/>
-            <a:ext cx="311582" cy="1639794"/>
+          <p:cNvPr id="35" name="Shape 32"/>
+          <p:cNvSpPr/>
+          <p:nvPr/>
+        </p:nvSpPr>
+        <p:spPr>
+          <a:xfrm>
+            <a:off x="8111345" y="2530511"/>
+            <a:ext cx="380528" cy="1401409"/>
           </a:xfrm>
           <a:prstGeom prst="rect">
             <a:avLst/>
@@ -2517,14 +2097,14 @@
       </p:sp>
       <p:sp>
         <p:nvSpPr>
-          <p:cNvPr id="48" name="Text 45"/>
-          <p:cNvSpPr/>
-          <p:nvPr/>
-        </p:nvSpPr>
-        <p:spPr>
-          <a:xfrm>
-            <a:off x="7940078" y="1935510"/>
-            <a:ext cx="531038" cy="164592"/>
+          <p:cNvPr id="36" name="Text 33"/>
+          <p:cNvSpPr/>
+          <p:nvPr/>
+        </p:nvSpPr>
+        <p:spPr>
+          <a:xfrm>
+            <a:off x="8001617" y="2292767"/>
+            <a:ext cx="599984" cy="164592"/>
           </a:xfrm>
           <a:prstGeom prst="rect">
             <a:avLst/>
@@ -2558,14 +2138,14 @@
       </p:sp>
       <p:sp>
         <p:nvSpPr>
-          <p:cNvPr id="49" name="Text 46"/>
-          <p:cNvSpPr/>
-          <p:nvPr/>
-        </p:nvSpPr>
-        <p:spPr>
-          <a:xfrm>
-            <a:off x="7786116" y="3941064"/>
-            <a:ext cx="838962" cy="310896"/>
+          <p:cNvPr id="37" name="Text 34"/>
+          <p:cNvSpPr/>
+          <p:nvPr/>
+        </p:nvSpPr>
+        <p:spPr>
+          <a:xfrm>
+            <a:off x="7822692" y="4059936"/>
+            <a:ext cx="957834" cy="310896"/>
           </a:xfrm>
           <a:prstGeom prst="rect">
             <a:avLst/>
@@ -2616,14 +2196,14 @@
       </p:sp>
       <p:sp>
         <p:nvSpPr>
-          <p:cNvPr id="50" name="Shape 47"/>
-          <p:cNvSpPr/>
-          <p:nvPr/>
-        </p:nvSpPr>
-        <p:spPr>
-          <a:xfrm>
-            <a:off x="8943632" y="1944929"/>
-            <a:ext cx="311582" cy="1868119"/>
+          <p:cNvPr id="38" name="Shape 35"/>
+          <p:cNvSpPr/>
+          <p:nvPr/>
+        </p:nvSpPr>
+        <p:spPr>
+          <a:xfrm>
+            <a:off x="9124043" y="2335378"/>
+            <a:ext cx="380528" cy="1596542"/>
           </a:xfrm>
           <a:prstGeom prst="rect">
             <a:avLst/>
@@ -2645,14 +2225,14 @@
       </p:sp>
       <p:sp>
         <p:nvSpPr>
-          <p:cNvPr id="51" name="Text 48"/>
-          <p:cNvSpPr/>
-          <p:nvPr/>
-        </p:nvSpPr>
-        <p:spPr>
-          <a:xfrm>
-            <a:off x="8833904" y="1707185"/>
-            <a:ext cx="531038" cy="164592"/>
+          <p:cNvPr id="39" name="Text 36"/>
+          <p:cNvSpPr/>
+          <p:nvPr/>
+        </p:nvSpPr>
+        <p:spPr>
+          <a:xfrm>
+            <a:off x="9014315" y="2097634"/>
+            <a:ext cx="599984" cy="164592"/>
           </a:xfrm>
           <a:prstGeom prst="rect">
             <a:avLst/>
@@ -2686,14 +2266,14 @@
       </p:sp>
       <p:sp>
         <p:nvSpPr>
-          <p:cNvPr id="52" name="Text 49"/>
-          <p:cNvSpPr/>
-          <p:nvPr/>
-        </p:nvSpPr>
-        <p:spPr>
-          <a:xfrm>
-            <a:off x="8679942" y="3941064"/>
-            <a:ext cx="838962" cy="310896"/>
+          <p:cNvPr id="40" name="Text 37"/>
+          <p:cNvSpPr/>
+          <p:nvPr/>
+        </p:nvSpPr>
+        <p:spPr>
+          <a:xfrm>
+            <a:off x="8835390" y="4059936"/>
+            <a:ext cx="957834" cy="310896"/>
           </a:xfrm>
           <a:prstGeom prst="rect">
             <a:avLst/>
@@ -2744,14 +2324,14 @@
       </p:sp>
       <p:sp>
         <p:nvSpPr>
-          <p:cNvPr id="53" name="Shape 50"/>
-          <p:cNvSpPr/>
-          <p:nvPr/>
-        </p:nvSpPr>
-        <p:spPr>
-          <a:xfrm>
-            <a:off x="6417945" y="2900751"/>
-            <a:ext cx="893826" cy="-249083"/>
+          <p:cNvPr id="41" name="Shape 38"/>
+          <p:cNvSpPr/>
+          <p:nvPr/>
+        </p:nvSpPr>
+        <p:spPr>
+          <a:xfrm>
+            <a:off x="6276213" y="3173517"/>
+            <a:ext cx="1012698" cy="-212872"/>
           </a:xfrm>
           <a:prstGeom prst="line">
             <a:avLst/>
@@ -2767,14 +2347,14 @@
       </p:sp>
       <p:sp>
         <p:nvSpPr>
-          <p:cNvPr id="54" name="Shape 51"/>
-          <p:cNvSpPr/>
-          <p:nvPr/>
-        </p:nvSpPr>
-        <p:spPr>
-          <a:xfrm>
-            <a:off x="7311771" y="2651669"/>
-            <a:ext cx="893826" cy="-332110"/>
+          <p:cNvPr id="42" name="Shape 39"/>
+          <p:cNvSpPr/>
+          <p:nvPr/>
+        </p:nvSpPr>
+        <p:spPr>
+          <a:xfrm>
+            <a:off x="7288911" y="2960644"/>
+            <a:ext cx="1012698" cy="-283830"/>
           </a:xfrm>
           <a:prstGeom prst="line">
             <a:avLst/>
@@ -2790,14 +2370,14 @@
       </p:sp>
       <p:sp>
         <p:nvSpPr>
-          <p:cNvPr id="55" name="Shape 52"/>
-          <p:cNvSpPr/>
-          <p:nvPr/>
-        </p:nvSpPr>
-        <p:spPr>
-          <a:xfrm>
-            <a:off x="8205597" y="2319558"/>
-            <a:ext cx="893826" cy="-228326"/>
+          <p:cNvPr id="43" name="Shape 40"/>
+          <p:cNvSpPr/>
+          <p:nvPr/>
+        </p:nvSpPr>
+        <p:spPr>
+          <a:xfrm>
+            <a:off x="8301609" y="2676815"/>
+            <a:ext cx="1012698" cy="-195133"/>
           </a:xfrm>
           <a:prstGeom prst="line">
             <a:avLst/>
@@ -2813,13 +2393,13 @@
       </p:sp>
       <p:sp>
         <p:nvSpPr>
-          <p:cNvPr id="56" name="Shape 53"/>
-          <p:cNvSpPr/>
-          <p:nvPr/>
-        </p:nvSpPr>
-        <p:spPr>
-          <a:xfrm>
-            <a:off x="6363081" y="2845887"/>
+          <p:cNvPr id="44" name="Shape 41"/>
+          <p:cNvSpPr/>
+          <p:nvPr/>
+        </p:nvSpPr>
+        <p:spPr>
+          <a:xfrm>
+            <a:off x="6221349" y="3118653"/>
             <a:ext cx="109728" cy="109728"/>
           </a:xfrm>
           <a:prstGeom prst="ellipse">
@@ -2838,13 +2418,13 @@
       </p:sp>
       <p:sp>
         <p:nvSpPr>
-          <p:cNvPr id="57" name="Shape 54"/>
-          <p:cNvSpPr/>
-          <p:nvPr/>
-        </p:nvSpPr>
-        <p:spPr>
-          <a:xfrm>
-            <a:off x="7256907" y="2596805"/>
+          <p:cNvPr id="45" name="Shape 42"/>
+          <p:cNvSpPr/>
+          <p:nvPr/>
+        </p:nvSpPr>
+        <p:spPr>
+          <a:xfrm>
+            <a:off x="7234047" y="2905780"/>
             <a:ext cx="109728" cy="109728"/>
           </a:xfrm>
           <a:prstGeom prst="ellipse">
@@ -2863,13 +2443,13 @@
       </p:sp>
       <p:sp>
         <p:nvSpPr>
-          <p:cNvPr id="58" name="Shape 55"/>
-          <p:cNvSpPr/>
-          <p:nvPr/>
-        </p:nvSpPr>
-        <p:spPr>
-          <a:xfrm>
-            <a:off x="8150733" y="2264694"/>
+          <p:cNvPr id="46" name="Shape 43"/>
+          <p:cNvSpPr/>
+          <p:nvPr/>
+        </p:nvSpPr>
+        <p:spPr>
+          <a:xfrm>
+            <a:off x="8246745" y="2621951"/>
             <a:ext cx="109728" cy="109728"/>
           </a:xfrm>
           <a:prstGeom prst="ellipse">
@@ -2888,13 +2468,13 @@
       </p:sp>
       <p:sp>
         <p:nvSpPr>
-          <p:cNvPr id="59" name="Shape 56"/>
-          <p:cNvSpPr/>
-          <p:nvPr/>
-        </p:nvSpPr>
-        <p:spPr>
-          <a:xfrm>
-            <a:off x="9044559" y="2036369"/>
+          <p:cNvPr id="47" name="Shape 44"/>
+          <p:cNvSpPr/>
+          <p:nvPr/>
+        </p:nvSpPr>
+        <p:spPr>
+          <a:xfrm>
+            <a:off x="9259443" y="2426818"/>
             <a:ext cx="109728" cy="109728"/>
           </a:xfrm>
           <a:prstGeom prst="ellipse">
@@ -2913,14 +2493,14 @@
       </p:sp>
       <p:sp>
         <p:nvSpPr>
-          <p:cNvPr id="60" name="Text 57"/>
-          <p:cNvSpPr/>
-          <p:nvPr/>
-        </p:nvSpPr>
-        <p:spPr>
-          <a:xfrm>
-            <a:off x="6455664" y="4343400"/>
-            <a:ext cx="3255264" cy="109728"/>
+          <p:cNvPr id="48" name="Text 45"/>
+          <p:cNvSpPr/>
+          <p:nvPr/>
+        </p:nvSpPr>
+        <p:spPr>
+          <a:xfrm>
+            <a:off x="6254496" y="4462272"/>
+            <a:ext cx="3730752" cy="109728"/>
           </a:xfrm>
           <a:prstGeom prst="rect">
             <a:avLst/>
@@ -2954,7 +2534,278 @@
       </p:sp>
       <p:sp>
         <p:nvSpPr>
-          <p:cNvPr id="61" name="Text 58"/>
+          <p:cNvPr id="49" name="Shape 46"/>
+          <p:cNvSpPr/>
+          <p:nvPr/>
+        </p:nvSpPr>
+        <p:spPr>
+          <a:xfrm>
+            <a:off x="5394960" y="4681728"/>
+            <a:ext cx="4553712" cy="0"/>
+          </a:xfrm>
+          <a:prstGeom prst="line">
+            <a:avLst/>
+          </a:prstGeom>
+          <a:noFill/>
+          <a:ln w="12700">
+            <a:solidFill>
+              <a:srgbClr val="6A625C">
+                <a:alpha val="78000"/>
+              </a:srgbClr>
+            </a:solidFill>
+            <a:prstDash val="solid"/>
+          </a:ln>
+        </p:spPr>
+      </p:sp>
+      <p:sp>
+        <p:nvSpPr>
+          <p:cNvPr id="50" name="Text 47"/>
+          <p:cNvSpPr/>
+          <p:nvPr/>
+        </p:nvSpPr>
+        <p:spPr>
+          <a:xfrm>
+            <a:off x="5394960" y="4773168"/>
+            <a:ext cx="1371600" cy="310896"/>
+          </a:xfrm>
+          <a:prstGeom prst="rect">
+            <a:avLst/>
+          </a:prstGeom>
+          <a:noFill/>
+          <a:ln/>
+        </p:spPr>
+        <p:txBody>
+          <a:bodyPr wrap="square" lIns="0" tIns="0" rIns="0" bIns="0" rtlCol="0" anchor="ctr">
+            <a:normAutofit/>
+          </a:bodyPr>
+          <a:lstStyle/>
+          <a:p>
+            <a:pPr indent="0" marL="0">
+              <a:buNone/>
+            </a:pPr>
+            <a:r>
+              <a:rPr lang="en-US" sz="1820" b="1" dirty="0">
+                <a:solidFill>
+                  <a:srgbClr val="D8B889"/>
+                </a:solidFill>
+                <a:latin typeface="PingFang SC" pitchFamily="34" charset="0"/>
+                <a:ea typeface="PingFang SC" pitchFamily="34" charset="-122"/>
+                <a:cs typeface="PingFang SC" pitchFamily="34" charset="-120"/>
+              </a:rPr>
+              <a:t>57%</a:t>
+            </a:r>
+            <a:endParaRPr lang="en-US" sz="1820" dirty="0"/>
+          </a:p>
+        </p:txBody>
+      </p:sp>
+      <p:sp>
+        <p:nvSpPr>
+          <p:cNvPr id="51" name="Text 48"/>
+          <p:cNvSpPr/>
+          <p:nvPr/>
+        </p:nvSpPr>
+        <p:spPr>
+          <a:xfrm>
+            <a:off x="5394960" y="5166360"/>
+            <a:ext cx="1371600" cy="201168"/>
+          </a:xfrm>
+          <a:prstGeom prst="rect">
+            <a:avLst/>
+          </a:prstGeom>
+          <a:noFill/>
+          <a:ln/>
+        </p:spPr>
+        <p:txBody>
+          <a:bodyPr wrap="square" lIns="0" tIns="0" rIns="0" bIns="0" rtlCol="0" anchor="ctr">
+            <a:normAutofit/>
+          </a:bodyPr>
+          <a:lstStyle/>
+          <a:p>
+            <a:pPr indent="0" marL="0">
+              <a:buNone/>
+            </a:pPr>
+            <a:r>
+              <a:rPr lang="en-US" sz="700" b="1" dirty="0">
+                <a:solidFill>
+                  <a:srgbClr val="D8CFC5"/>
+                </a:solidFill>
+                <a:latin typeface="PingFang SC" pitchFamily="34" charset="0"/>
+                <a:ea typeface="PingFang SC" pitchFamily="34" charset="-122"/>
+                <a:cs typeface="PingFang SC" pitchFamily="34" charset="-120"/>
+              </a:rPr>
+              <a:t>选题复用</a:t>
+            </a:r>
+            <a:endParaRPr lang="en-US" sz="700" dirty="0"/>
+          </a:p>
+        </p:txBody>
+      </p:sp>
+      <p:sp>
+        <p:nvSpPr>
+          <p:cNvPr id="52" name="Text 49"/>
+          <p:cNvSpPr/>
+          <p:nvPr/>
+        </p:nvSpPr>
+        <p:spPr>
+          <a:xfrm>
+            <a:off x="6912864" y="4773168"/>
+            <a:ext cx="1371600" cy="310896"/>
+          </a:xfrm>
+          <a:prstGeom prst="rect">
+            <a:avLst/>
+          </a:prstGeom>
+          <a:noFill/>
+          <a:ln/>
+        </p:spPr>
+        <p:txBody>
+          <a:bodyPr wrap="square" lIns="0" tIns="0" rIns="0" bIns="0" rtlCol="0" anchor="ctr">
+            <a:normAutofit/>
+          </a:bodyPr>
+          <a:lstStyle/>
+          <a:p>
+            <a:pPr indent="0" marL="0">
+              <a:buNone/>
+            </a:pPr>
+            <a:r>
+              <a:rPr lang="en-US" sz="1820" b="1" dirty="0">
+                <a:solidFill>
+                  <a:srgbClr val="F5EFE6"/>
+                </a:solidFill>
+                <a:latin typeface="PingFang SC" pitchFamily="34" charset="0"/>
+                <a:ea typeface="PingFang SC" pitchFamily="34" charset="-122"/>
+                <a:cs typeface="PingFang SC" pitchFamily="34" charset="-120"/>
+              </a:rPr>
+              <a:t>2.8x</a:t>
+            </a:r>
+            <a:endParaRPr lang="en-US" sz="1820" dirty="0"/>
+          </a:p>
+        </p:txBody>
+      </p:sp>
+      <p:sp>
+        <p:nvSpPr>
+          <p:cNvPr id="53" name="Text 50"/>
+          <p:cNvSpPr/>
+          <p:nvPr/>
+        </p:nvSpPr>
+        <p:spPr>
+          <a:xfrm>
+            <a:off x="6912864" y="5166360"/>
+            <a:ext cx="1371600" cy="201168"/>
+          </a:xfrm>
+          <a:prstGeom prst="rect">
+            <a:avLst/>
+          </a:prstGeom>
+          <a:noFill/>
+          <a:ln/>
+        </p:spPr>
+        <p:txBody>
+          <a:bodyPr wrap="square" lIns="0" tIns="0" rIns="0" bIns="0" rtlCol="0" anchor="ctr">
+            <a:normAutofit/>
+          </a:bodyPr>
+          <a:lstStyle/>
+          <a:p>
+            <a:pPr indent="0" marL="0">
+              <a:buNone/>
+            </a:pPr>
+            <a:r>
+              <a:rPr lang="en-US" sz="700" b="1" dirty="0">
+                <a:solidFill>
+                  <a:srgbClr val="D8CFC5"/>
+                </a:solidFill>
+                <a:latin typeface="PingFang SC" pitchFamily="34" charset="0"/>
+                <a:ea typeface="PingFang SC" pitchFamily="34" charset="-122"/>
+                <a:cs typeface="PingFang SC" pitchFamily="34" charset="-120"/>
+              </a:rPr>
+              <a:t>审稿提速</a:t>
+            </a:r>
+            <a:endParaRPr lang="en-US" sz="700" dirty="0"/>
+          </a:p>
+        </p:txBody>
+      </p:sp>
+      <p:sp>
+        <p:nvSpPr>
+          <p:cNvPr id="54" name="Text 51"/>
+          <p:cNvSpPr/>
+          <p:nvPr/>
+        </p:nvSpPr>
+        <p:spPr>
+          <a:xfrm>
+            <a:off x="8430768" y="4773168"/>
+            <a:ext cx="1371600" cy="310896"/>
+          </a:xfrm>
+          <a:prstGeom prst="rect">
+            <a:avLst/>
+          </a:prstGeom>
+          <a:noFill/>
+          <a:ln/>
+        </p:spPr>
+        <p:txBody>
+          <a:bodyPr wrap="square" lIns="0" tIns="0" rIns="0" bIns="0" rtlCol="0" anchor="ctr">
+            <a:normAutofit/>
+          </a:bodyPr>
+          <a:lstStyle/>
+          <a:p>
+            <a:pPr indent="0" marL="0">
+              <a:buNone/>
+            </a:pPr>
+            <a:r>
+              <a:rPr lang="en-US" sz="1820" b="1" dirty="0">
+                <a:solidFill>
+                  <a:srgbClr val="9D3340"/>
+                </a:solidFill>
+                <a:latin typeface="PingFang SC" pitchFamily="34" charset="0"/>
+                <a:ea typeface="PingFang SC" pitchFamily="34" charset="-122"/>
+                <a:cs typeface="PingFang SC" pitchFamily="34" charset="-120"/>
+              </a:rPr>
+              <a:t>2026</a:t>
+            </a:r>
+            <a:endParaRPr lang="en-US" sz="1820" dirty="0"/>
+          </a:p>
+        </p:txBody>
+      </p:sp>
+      <p:sp>
+        <p:nvSpPr>
+          <p:cNvPr id="55" name="Text 52"/>
+          <p:cNvSpPr/>
+          <p:nvPr/>
+        </p:nvSpPr>
+        <p:spPr>
+          <a:xfrm>
+            <a:off x="8430768" y="5166360"/>
+            <a:ext cx="1371600" cy="201168"/>
+          </a:xfrm>
+          <a:prstGeom prst="rect">
+            <a:avLst/>
+          </a:prstGeom>
+          <a:noFill/>
+          <a:ln/>
+        </p:spPr>
+        <p:txBody>
+          <a:bodyPr wrap="square" lIns="0" tIns="0" rIns="0" bIns="0" rtlCol="0" anchor="ctr">
+            <a:normAutofit/>
+          </a:bodyPr>
+          <a:lstStyle/>
+          <a:p>
+            <a:pPr indent="0" marL="0">
+              <a:buNone/>
+            </a:pPr>
+            <a:r>
+              <a:rPr lang="en-US" sz="700" b="1" dirty="0">
+                <a:solidFill>
+                  <a:srgbClr val="D8CFC5"/>
+                </a:solidFill>
+                <a:latin typeface="PingFang SC" pitchFamily="34" charset="0"/>
+                <a:ea typeface="PingFang SC" pitchFamily="34" charset="-122"/>
+                <a:cs typeface="PingFang SC" pitchFamily="34" charset="-120"/>
+              </a:rPr>
+              <a:t>内容复利</a:t>
+            </a:r>
+            <a:endParaRPr lang="en-US" sz="700" dirty="0"/>
+          </a:p>
+        </p:txBody>
+      </p:sp>
+      <p:sp>
+        <p:nvSpPr>
+          <p:cNvPr id="56" name="Text 53"/>
           <p:cNvSpPr/>
           <p:nvPr/>
         </p:nvSpPr>

</xml_diff>